<commit_message>
Remove the physician antibiotic letter study and tidy the flow
- Delete the social-norm letter slide on antibiotic prescribing and the
  speaker-note references to it.
- Part 3 section slide now reads diagnose / show / nudge; renumber the
  hospital-practice label to 見える化②.
- Replace the physician row in the profession table with a hand hygiene
  example (leader goes first on rounds).
- Update timing notes and the reference list PDF.

Co-Authored-By: Claude Opus 5.5 <noreply@anthropic.com>
Claude-Session: https://claude.ai/code/session_014JLF6BU4cEobehYG53BRV1
</commit_message>
<xml_diff>
--- a/lectures/behavioral-science-invisible-enemy/行動科学は感染対策の見えない敵を可視化する.pptx
+++ b/lectures/behavioral-science-invisible-enemy/行動科学は感染対策の見えない敵を可視化する.pptx
@@ -37,7 +37,6 @@
     <p:sldId id="281" r:id="rId27"/>
     <p:sldId id="282" r:id="rId28"/>
     <p:sldId id="283" r:id="rId29"/>
-    <p:sldId id="284" r:id="rId30"/>
     <p:sldId id="306" r:id="rId57"/>
     <p:sldId id="301" r:id="rId52"/>
     <p:sldId id="302" r:id="rId53"/>
@@ -3808,7 +3807,7 @@
             <a:r>
               <a:rPr lang="en-US" dirty="0"/>
               <a:t>【目安20秒／30:15–30:35】
-第3部では、これらの見えない敵を「見える化」する方法を、診断する・見せる・返す、の3つの視点でご紹介します。</a:t>
+第3部では、これらの見えない敵を「見える化」する方法を、診断する・見せる・後押しする、の3つの視点でご紹介します。</a:t>
             </a:r>
           </a:p>
         </p:txBody>
@@ -4304,98 +4303,6 @@
 </p:notes>
 </file>
 
-<file path=ppt/notesSlides/notesSlide29.xml><?xml version="1.0" encoding="utf-8"?>
-<p:notes xmlns:a="http://schemas.openxmlformats.org/drawingml/2006/main" xmlns:r="http://schemas.openxmlformats.org/officeDocument/2006/relationships" xmlns:p="http://schemas.openxmlformats.org/presentationml/2006/main">
-  <p:cSld>
-    <p:spTree>
-      <p:nvGrpSpPr>
-        <p:cNvPr id="1" name=""/>
-        <p:cNvGrpSpPr/>
-        <p:nvPr/>
-      </p:nvGrpSpPr>
-      <p:grpSpPr>
-        <a:xfrm>
-          <a:off x="0" y="0"/>
-          <a:ext cx="0" cy="0"/>
-          <a:chOff x="0" y="0"/>
-          <a:chExt cx="0" cy="0"/>
-        </a:xfrm>
-      </p:grpSpPr>
-      <p:sp>
-        <p:nvSpPr>
-          <p:cNvPr id="2" name="Slide Image Placeholder 1"/>
-          <p:cNvSpPr>
-            <a:spLocks noGrp="1" noRot="1" noChangeAspect="1"/>
-          </p:cNvSpPr>
-          <p:nvPr>
-            <p:ph type="sldImg"/>
-          </p:nvPr>
-        </p:nvSpPr>
-        <p:spPr/>
-      </p:sp>
-      <p:sp>
-        <p:nvSpPr>
-          <p:cNvPr id="3" name="Notes Placeholder 2"/>
-          <p:cNvSpPr>
-            <a:spLocks noGrp="1"/>
-          </p:cNvSpPr>
-          <p:nvPr>
-            <p:ph type="body" idx="1"/>
-          </p:nvPr>
-        </p:nvSpPr>
-        <p:spPr/>
-        <p:txBody>
-          <a:bodyPr/>
-          <a:lstStyle/>
-          <a:p>
-            <a:r>
-              <a:rPr lang="en-US" dirty="0"/>
-              <a:t>【目安1分30秒／38:15–39:45】
-次は「数字で返す」です。英国で1,581の診療所を対象に行われたランダム化比較試験です。
-抗菌薬処方が地域の上位20%に入る診療所の医師に、イングランドの主席医務官から「あなたの診療所の処方は、地域の80%の診療所より多い」という手紙を1通送りました。
-その結果、6か月間の処方は3.3%減り、推計で約7万3千件の処方が減りました。低コストで全国規模の効果です。
-自分の位置が「見える」と、人は行動を修正します。
-（出典：Hallsworth M, et al. Lancet 2016;387:1743-52）</a:t>
-            </a:r>
-          </a:p>
-        </p:txBody>
-      </p:sp>
-      <p:sp>
-        <p:nvSpPr>
-          <p:cNvPr id="4" name="Slide Number Placeholder 3"/>
-          <p:cNvSpPr>
-            <a:spLocks noGrp="1"/>
-          </p:cNvSpPr>
-          <p:nvPr>
-            <p:ph type="sldNum" sz="quarter" idx="10"/>
-          </p:nvPr>
-        </p:nvSpPr>
-        <p:spPr/>
-        <p:txBody>
-          <a:bodyPr/>
-          <a:lstStyle/>
-          <a:p>
-            <a:fld id="{F7021451-1387-4CA6-816F-3879F97B5CBC}" type="slidenum">
-              <a:rPr lang="en-US"/>
-              <a:t>29</a:t>
-            </a:fld>
-            <a:endParaRPr lang="en-US"/>
-          </a:p>
-        </p:txBody>
-      </p:sp>
-    </p:spTree>
-    <p:extLst>
-      <p:ext uri="{BB962C8B-B14F-4D97-AF65-F5344CB8AC3E}">
-        <p14:creationId xmlns:p14="http://schemas.microsoft.com/office/powerpoint/2010/main" val="1024086991"/>
-      </p:ext>
-    </p:extLst>
-  </p:cSld>
-  <p:clrMapOvr>
-    <a:masterClrMapping/>
-  </p:clrMapOvr>
-</p:notes>
-</file>
-
 <file path=ppt/notesSlides/notesSlide3.xml><?xml version="1.0" encoding="utf-8"?>
 <p:notes xmlns:a="http://schemas.openxmlformats.org/drawingml/2006/main" xmlns:r="http://schemas.openxmlformats.org/officeDocument/2006/relationships" xmlns:p="http://schemas.openxmlformats.org/presentationml/2006/main">
   <p:cSld>
@@ -4531,7 +4438,7 @@
           <a:p>
             <a:r>
               <a:rPr lang="en-US" dirty="0"/>
-              <a:t>【目安1分30秒／45:15–46:45】
+              <a:t>【目安1分30秒／43:45–45:15】
 結果です。病院全体の手指消毒剤の使用量は、2018年度の1000患者日あたり12.6Lから、2024年度は26.3Lへ、約2.1倍に増えました。全13部署で統計学的に有意な増加でした。なお、コロナ禍の影響が大きい2020〜2023年度は比較から除いています。
 一方で、直接観察による遵守率には大きな伸びは見られていません。ただ、コロナ禍を経ても低下せずに維持できています。
 単年度の前後比較であり、使用量イコール遵守率ではない、という限界もあります。だからこそ、先ほどお話しした「複数の物差し」で見ていくことが大切だと考えています。看護師以外の職種へのアプローチが今後の課題です。</a:t>
@@ -4621,7 +4528,7 @@
           <a:p>
             <a:r>
               <a:rPr lang="en-US" dirty="0"/>
-              <a:t>【目安20秒／46:45–47:05】
+              <a:t>【目安20秒／45:15–45:35】
 第4部では、明日から「仕掛ける」ための具体的な手順をお伝えします。</a:t>
             </a:r>
           </a:p>
@@ -4709,7 +4616,7 @@
           <a:p>
             <a:r>
               <a:rPr lang="en-US" dirty="0"/>
-              <a:t>【目安1分20秒／47:05–48:25】
+              <a:t>【目安1分20秒／45:35–46:55】
 見える化は4つのステップで進めます。
 ①絞る：「手指衛生を頑張る」ではなく、「誰が、いつ、どこで、何をするか」を1つに絞ります。②診断する：COM-Bで、能力・機会・動機のどこに原因があるかを探します。③仕掛ける：次にご紹介するEASTの視点で、環境や伝え方を変えます。④返す：測った結果を、現場に見える形で返します。
 大きな計画より、小さく始めて回すことが成功のコツです。</a:t>
@@ -4799,7 +4706,7 @@
           <a:p>
             <a:r>
               <a:rPr lang="en-US" dirty="0"/>
-              <a:t>【目安1分30秒／48:25–49:55】
+              <a:t>【目安1分30秒／46:55–48:25】
 仕掛けを考えるときのチェックリストが、英国の行動インサイトチームが提唱するEASTです。
 Easy、簡単に：消毒剤を動線上や手の届くところに置く、手順を番号にする。Attractive、魅力的に：「患者さんを守る」を主語にする、目を引く表示にする。Social、社会的に：部署の実施状況を共有する、リーダーが率先する。Timely、タイミングよく：入室の直前や、手袋を外した直後に合図を出す。
 今日ご紹介した研究の多くは、この4つのどれかに当てはまります。
@@ -4977,9 +4884,9 @@
           <a:p>
             <a:r>
               <a:rPr lang="en-US" dirty="0"/>
-              <a:t>【目安1分50秒／50:55–52:45】
+              <a:t>【目安1分50秒／49:25–51:15】
 「見えない敵」は職種によって姿を変えます。
-医師は自分の処方の多さが見えにくいため、先ほどの手紙のような同僚比較のフィードバックが有効です。看護師は繁忙時の「触れる前」のスキップに、動線上の消毒剤と合図を。薬剤師は処方の偏りを、抗菌薬の使用データとして部署に返すことができます。臨床検査技師は、耐性菌の検出状況を部署別に見える化できます。リハビリや放射線は、機器や環境に触れた後の手指衛生。清掃や看護補助は、蛍光マーカーによるフィードバック。事務・管理者は、物品の配置や使用量を定期的に共有する。
+医師は回診などで「触れる前」が抜けやすいため、先頭に立つ人が最初に手指衛生をすることが、研修医への手本にもなります。看護師は繁忙時の「触れる前」のスキップに、動線上の消毒剤と合図を。薬剤師は処方の偏りを、抗菌薬の使用データとして部署に返すことができます。臨床検査技師は、耐性菌の検出状況を部署別に見える化できます。リハビリや放射線は、機器や環境に触れた後の手指衛生。清掃や看護補助は、蛍光マーカーによるフィードバック。事務・管理者は、物品の配置や使用量を定期的に共有する。
 どの職種にも、見える化の担い手としての役割があります。
 ※表の例は、本日ご紹介した研究をもとにした応用例です。</a:t>
             </a:r>
@@ -5159,7 +5066,7 @@
           <a:p>
             <a:r>
               <a:rPr lang="en-US" dirty="0"/>
-              <a:t>【目安1分／54:15–55:15】
+              <a:t>【目安1分／52:45–53:45】
 最後に、科学的に誠実であるために。手指衛生の介入を検証したコクランレビューでは、消毒剤を使用場所の近くに置くことは中等度の確実性で改善が期待できる一方、フィードバック、教育、掲示や香りなどのきっかけ、多角的な介入の多くは、効果が示唆されるものの確実性は低い、とされています。
 WHOの多角的戦略も、システムの変更、教育、モニタリングとフィードバック、職場でのリマインダー、安全文化を組み合わせることを求めています。
 ナッジは万能薬ではありません。組み合わせて、測って、直す。この繰り返しが大切です。
@@ -5250,7 +5157,7 @@
           <a:p>
             <a:r>
               <a:rPr lang="en-US" dirty="0"/>
-              <a:t>【目安2分／55:15–57:15】
+              <a:t>【目安2分／53:45–55:45】
 では1分間、考えてみてください。お手元の紙にメモしていただいても構いません。
 ①あなたの職場で変えたい行動を1つ、誰が・いつ・どこで・何をするかまで絞ってください。②その行動を邪魔している見えない敵は、5つのうちどれでしょうか。③明日できる一手は何でしょうか。見せる、返す、仕掛ける、のどれでも構いません。
 （1分後）
@@ -5341,7 +5248,7 @@
           <a:p>
             <a:r>
               <a:rPr lang="en-US" dirty="0"/>
-              <a:t>【目安1分／57:15–58:15】
+              <a:t>【目安1分／55:45–56:45】
 まとめです。
 一つ、行動の原因は目に見えません。人を責める前に、仕組みを疑いましょう。
 二つ、行動科学、特にCOM-Bを使えば、見えない敵を診断できます。
@@ -5432,7 +5339,7 @@
           <a:p>
             <a:r>
               <a:rPr lang="en-US" dirty="0"/>
-              <a:t>【目安30秒／58:15–58:45】
+              <a:t>【目安30秒／56:45–57:15】
 見えない敵は、「人の中」ではなく「仕組みの中」にいます。
 明日、ひとつだけ、仕掛けてみませんか。</a:t>
             </a:r>
@@ -5521,7 +5428,7 @@
           <a:p>
             <a:r>
               <a:rPr lang="en-US" dirty="0"/>
-              <a:t>【目安1分／40:45–41:45】
+              <a:t>【目安1分／39:15–40:15】
 人の行動を変える道具を、大きく4つに分けてみます。
 1つ目はルール。「必ずこうする」という義務や禁止です。2つ目はお金。ごほうびや罰金です。3つ目は教育。知識を伝える研修やマニュアルです。そして4つ目がナッジ。選択肢や環境の「見せ方・置き方」を設計して、自然に選びやすくします。
 例えば手指衛生なら、手順を決めるのがルール、研修をするのが教育、入口の動線上に消毒剤を置いたり、足あとで誘導したりするのがナッジです。
@@ -5614,7 +5521,7 @@
           <a:p>
             <a:r>
               <a:rPr lang="en-US" dirty="0"/>
-              <a:t>【目安1分／41:45–42:45】
+              <a:t>【目安1分／40:15–41:15】
 ナッジの中でも特に強力なのが「初期設定（デフォルト）」です。
 臓器提供の意思をたずねるオンライン実験で、「提供したい人がチェックを入れる」聞き方では、同意した人は約42%でした。ところが「提供したくない人がチェックを外す」、つまり最初から同意が選ばれている聞き方では、約82%に上がりました。選ぶ自由はどちらも同じです。変えたのは「最初の設定」だけです。
 国別に見ても、同意が初期設定になっている国では、実際の同意率が90%を超える国が多く見られました。
@@ -5707,7 +5614,7 @@
           <a:p>
             <a:r>
               <a:rPr lang="en-US" dirty="0"/>
-              <a:t>【目安1分／42:45–43:45】
+              <a:t>【目安1分／41:15–42:15】
 このデフォルトは、感染対策でも使えます。
 米国の大学職員478名を対象にしたランダム化比較試験で、インフルエンザワクチンの案内を2通り送りました。「接種したい人は自分で予約してください」という案内では接種率33%。一方、「あなたの接種日時はすでに予約されています。都合が悪ければ変更・取消できます」という案内では45%でした。予約を取り消したのは8%だけでした。
 新型コロナワクチンでも、9万人以上を対象にした試験で、「あなたのためのワクチンが用意されています」と伝えるショートメッセージが、接種率を3.57ポイント押し上げました。
@@ -6076,11 +5983,10 @@
           <a:p>
             <a:r>
               <a:rPr lang="en-US" dirty="0"/>
-              <a:t>【目安1分／39:45–40:45】
+              <a:t>【目安1分／38:15–39:15】
 ここで、今日のキーワード「ナッジ」を確認しておきます。
 ナッジは英語で「ひじで軽くつつく」という意味です。行動経済学者のセイラーとサンスティーンが広めた考え方で、禁止や強制をしたり、お金で釣ったりせずに、選ぶ自由は残したまま、望ましい行動を「選びやすく」する工夫のことです。
 実は皆さんの身の回りにもあります。レジ前の足あとマークがあると、言われなくても間隔をあけて並びます。「一番人気」と書いてあると、ついそれを選びます。最初からチェックが入っている欄は、そのままにしがちです。
-先ほどの「1通の手紙」も、周りと比べた自分の位置を見せるナッジでした。
 第1部でお話しした「速い思考（システム1）」は、理屈より目の前の環境に反応します。ナッジは、その速い思考に働きかけて、考えなくても望ましい行動を選べるようにする方法です。
 （出典：Thaler RH, Sunstein CR. Nudge: Improving Decisions about Health, Wealth, and Happiness. Yale University Press; 2008）</a:t>
             </a:r>
@@ -6170,7 +6076,7 @@
           <a:p>
             <a:r>
               <a:rPr lang="en-US" dirty="0"/>
-              <a:t>【目安1分30秒／43:45–45:15】
+              <a:t>【目安1分30秒／42:15–43:45】
 ここで当院の実践をご紹介します。写真の3つは、いずれも「考えなくても手が動く」ことをねらったナッジです。
 一つ目は救急外来の入口です。床の足あとで手指消毒剤のスタンドへ誘導し、目立たせました。患者さんのご家族が入室時に手指消毒をする頻度が増えました。
 二つ目は病室の名札の下の表示です。「①氏名を確認したら、②手指消毒を2プッシュ」と、毎回必ず行う氏名確認を合図にして、次の行動を具体的に示しています。
@@ -6264,7 +6170,7 @@
           <a:p>
             <a:r>
               <a:rPr lang="en-US" dirty="0"/>
-              <a:t>【目安1分30秒／52:45–54:15】
+              <a:t>【目安1分30秒／51:15–52:45】
 組織として仕掛けた有名な例が、米国ミシガン州のICUプロジェクトです。
 やったことは、中心静脈カテーテルの感染を防ぐ、エビデンスのある5つの対策です。手指衛生、挿入時のマキシマル・バリアプリコーション、クロルヘキシジンによる皮膚消毒、できるだけ大腿部を避けること、不要なカテーテルを抜くこと。これを物品カートとチェックリストで支え、守られていなければ緊急時を除いて手技を止めることにしました。
 その結果、103のICUで、カテーテル関連血流感染は1000カテーテル日あたり平均7.7件から1.4件へ、最大66%減りました。
@@ -15965,7 +15871,7 @@
                 <a:ea typeface="BIZ UDゴシック" pitchFamily="49" charset="-128"/>
                 <a:cs typeface="BIZ UDゴシック" pitchFamily="34" charset="-120"/>
               </a:rPr>
-              <a:t>返す：数字で自分の位置を示す</a:t>
+              <a:t>後押しする：ナッジと当院の実践</a:t>
             </a:r>
             <a:endParaRPr lang="en-US" sz="2400" dirty="0"/>
           </a:p>
@@ -19843,653 +19749,6 @@
 </p:sld>
 </file>
 
-<file path=ppt/slides/slide29.xml><?xml version="1.0" encoding="utf-8"?>
-<p:sld xmlns:a="http://schemas.openxmlformats.org/drawingml/2006/main" xmlns:r="http://schemas.openxmlformats.org/officeDocument/2006/relationships" xmlns:p="http://schemas.openxmlformats.org/presentationml/2006/main">
-  <p:cSld name="Slide 29">
-    <p:bg>
-      <p:bgPr>
-        <a:solidFill>
-          <a:schemeClr val="bg1"/>
-        </a:solidFill>
-        <a:effectLst/>
-      </p:bgPr>
-    </p:bg>
-    <p:spTree>
-      <p:nvGrpSpPr>
-        <p:cNvPr id="1" name=""/>
-        <p:cNvGrpSpPr/>
-        <p:nvPr/>
-      </p:nvGrpSpPr>
-      <p:grpSpPr>
-        <a:xfrm>
-          <a:off x="0" y="0"/>
-          <a:ext cx="0" cy="0"/>
-          <a:chOff x="0" y="0"/>
-          <a:chExt cx="0" cy="0"/>
-        </a:xfrm>
-      </p:grpSpPr>
-      <p:sp>
-        <p:nvSpPr>
-          <p:cNvPr id="2" name="Shape 0"/>
-          <p:cNvSpPr/>
-          <p:nvPr/>
-        </p:nvSpPr>
-        <p:spPr>
-          <a:xfrm>
-            <a:off x="548640" y="347472"/>
-            <a:ext cx="3124200" cy="420624"/>
-          </a:xfrm>
-          <a:prstGeom prst="roundRect">
-            <a:avLst>
-              <a:gd name="adj" fmla="val 50000"/>
-            </a:avLst>
-          </a:prstGeom>
-          <a:solidFill>
-            <a:srgbClr val="0B7A70"/>
-          </a:solidFill>
-          <a:ln w="12700">
-            <a:solidFill>
-              <a:srgbClr val="0B7A70"/>
-            </a:solidFill>
-            <a:prstDash val="solid"/>
-          </a:ln>
-        </p:spPr>
-      </p:sp>
-      <p:sp>
-        <p:nvSpPr>
-          <p:cNvPr id="3" name="Text 1"/>
-          <p:cNvSpPr txBox="1"/>
-          <p:nvPr/>
-        </p:nvSpPr>
-        <p:spPr>
-          <a:xfrm>
-            <a:off x="548640" y="347472"/>
-            <a:ext cx="3124200" cy="420624"/>
-          </a:xfrm>
-          <a:prstGeom prst="rect">
-            <a:avLst/>
-          </a:prstGeom>
-          <a:noFill/>
-          <a:ln/>
-        </p:spPr>
-        <p:txBody>
-          <a:bodyPr wrap="square" lIns="0" tIns="0" rIns="0" bIns="0" rtlCol="0" anchor="ctr"/>
-          <a:lstStyle/>
-          <a:p>
-            <a:pPr marL="0" indent="0" algn="ctr">
-              <a:buNone/>
-            </a:pPr>
-            <a:r>
-              <a:rPr lang="en-US" sz="2000" b="1" dirty="0">
-                <a:solidFill>
-                  <a:srgbClr val="FFFFFF"/>
-                </a:solidFill>
-                <a:latin typeface="BIZ UDゴシック" pitchFamily="34" charset="0"/>
-                <a:ea typeface="BIZ UDゴシック" pitchFamily="49" charset="-128"/>
-                <a:cs typeface="BIZ UDゴシック" pitchFamily="34" charset="-120"/>
-              </a:rPr>
-              <a:t>見える化② 数字で返す</a:t>
-            </a:r>
-            <a:endParaRPr lang="en-US" sz="2000" dirty="0"/>
-          </a:p>
-        </p:txBody>
-      </p:sp>
-      <p:sp>
-        <p:nvSpPr>
-          <p:cNvPr id="4" name="Text 2"/>
-          <p:cNvSpPr txBox="1"/>
-          <p:nvPr/>
-        </p:nvSpPr>
-        <p:spPr>
-          <a:xfrm>
-            <a:off x="548640" y="868680"/>
-            <a:ext cx="11094415" cy="777240"/>
-          </a:xfrm>
-          <a:prstGeom prst="rect">
-            <a:avLst/>
-          </a:prstGeom>
-          <a:noFill/>
-          <a:ln/>
-        </p:spPr>
-        <p:txBody>
-          <a:bodyPr wrap="square" lIns="0" tIns="0" rIns="0" bIns="0" rtlCol="0" anchor="ctr"/>
-          <a:lstStyle/>
-          <a:p>
-            <a:pPr marL="0" indent="0">
-              <a:buNone/>
-            </a:pPr>
-            <a:r>
-              <a:rPr lang="en-US" sz="3200" b="1" dirty="0">
-                <a:solidFill>
-                  <a:srgbClr val="131B35"/>
-                </a:solidFill>
-                <a:latin typeface="BIZ UDゴシック" pitchFamily="34" charset="0"/>
-                <a:ea typeface="BIZ UDゴシック" pitchFamily="49" charset="-128"/>
-                <a:cs typeface="BIZ UDゴシック" pitchFamily="34" charset="-120"/>
-              </a:rPr>
-              <a:t>「あなたは上位20%」という1通の手紙が、処方を減らした</a:t>
-            </a:r>
-            <a:endParaRPr lang="en-US" sz="3200" dirty="0"/>
-          </a:p>
-        </p:txBody>
-      </p:sp>
-      <p:sp>
-        <p:nvSpPr>
-          <p:cNvPr id="5" name="Text 3"/>
-          <p:cNvSpPr txBox="1"/>
-          <p:nvPr/>
-        </p:nvSpPr>
-        <p:spPr>
-          <a:xfrm>
-            <a:off x="548640" y="6217920"/>
-            <a:ext cx="10058400" cy="384048"/>
-          </a:xfrm>
-          <a:prstGeom prst="rect">
-            <a:avLst/>
-          </a:prstGeom>
-          <a:noFill/>
-          <a:ln/>
-        </p:spPr>
-        <p:txBody>
-          <a:bodyPr wrap="square" lIns="0" tIns="0" rIns="0" bIns="0" rtlCol="0" anchor="ctr"/>
-          <a:lstStyle/>
-          <a:p>
-            <a:pPr marL="0" indent="0">
-              <a:buNone/>
-            </a:pPr>
-            <a:r>
-              <a:rPr lang="en-US" sz="2000" dirty="0">
-                <a:solidFill>
-                  <a:srgbClr val="4F5B6B"/>
-                </a:solidFill>
-                <a:latin typeface="BIZ UDゴシック" pitchFamily="34" charset="0"/>
-                <a:ea typeface="BIZ UDゴシック" pitchFamily="49" charset="-128"/>
-                <a:cs typeface="BIZ UDゴシック" pitchFamily="34" charset="-120"/>
-              </a:rPr>
-              <a:t>出典：Hallsworth M, et al. Lancet 2016</a:t>
-            </a:r>
-            <a:endParaRPr lang="en-US" sz="2000" dirty="0"/>
-          </a:p>
-        </p:txBody>
-      </p:sp>
-      <p:sp>
-        <p:nvSpPr>
-          <p:cNvPr id="7" name="Shape 4"/>
-          <p:cNvSpPr/>
-          <p:nvPr/>
-        </p:nvSpPr>
-        <p:spPr>
-          <a:xfrm>
-            <a:off x="548640" y="2011680"/>
-            <a:ext cx="5669280" cy="3931920"/>
-          </a:xfrm>
-          <a:prstGeom prst="roundRect">
-            <a:avLst>
-              <a:gd name="adj" fmla="val 2791"/>
-            </a:avLst>
-          </a:prstGeom>
-          <a:solidFill>
-            <a:srgbClr val="FFFFFF"/>
-          </a:solidFill>
-          <a:ln w="25400">
-            <a:solidFill>
-              <a:srgbClr val="8A96A8"/>
-            </a:solidFill>
-            <a:prstDash val="solid"/>
-          </a:ln>
-        </p:spPr>
-      </p:sp>
-      <p:sp>
-        <p:nvSpPr>
-          <p:cNvPr id="8" name="Shape 5"/>
-          <p:cNvSpPr/>
-          <p:nvPr/>
-        </p:nvSpPr>
-        <p:spPr>
-          <a:xfrm>
-            <a:off x="822960" y="2240280"/>
-            <a:ext cx="731520" cy="731520"/>
-          </a:xfrm>
-          <a:prstGeom prst="ellipse">
-            <a:avLst/>
-          </a:prstGeom>
-          <a:solidFill>
-            <a:srgbClr val="0B7A70"/>
-          </a:solidFill>
-          <a:ln w="12700">
-            <a:solidFill>
-              <a:srgbClr val="0B7A70"/>
-            </a:solidFill>
-            <a:prstDash val="solid"/>
-          </a:ln>
-        </p:spPr>
-      </p:sp>
-      <p:pic>
-        <p:nvPicPr>
-          <p:cNvPr id="9" name="Image 0" descr="preencoded.png"/>
-          <p:cNvPicPr>
-            <a:picLocks noChangeAspect="1"/>
-          </p:cNvPicPr>
-          <p:nvPr/>
-        </p:nvPicPr>
-        <p:blipFill>
-          <a:blip r:embed="rId3"/>
-          <a:stretch>
-            <a:fillRect/>
-          </a:stretch>
-        </p:blipFill>
-        <p:spPr>
-          <a:xfrm>
-            <a:off x="998525" y="2415845"/>
-            <a:ext cx="380390" cy="380390"/>
-          </a:xfrm>
-          <a:prstGeom prst="rect">
-            <a:avLst/>
-          </a:prstGeom>
-        </p:spPr>
-      </p:pic>
-      <p:sp>
-        <p:nvSpPr>
-          <p:cNvPr id="10" name="Text 6"/>
-          <p:cNvSpPr txBox="1"/>
-          <p:nvPr/>
-        </p:nvSpPr>
-        <p:spPr>
-          <a:xfrm>
-            <a:off x="1691640" y="2240280"/>
-            <a:ext cx="4389120" cy="731520"/>
-          </a:xfrm>
-          <a:prstGeom prst="rect">
-            <a:avLst/>
-          </a:prstGeom>
-          <a:noFill/>
-          <a:ln/>
-        </p:spPr>
-        <p:txBody>
-          <a:bodyPr wrap="square" lIns="0" tIns="0" rIns="0" bIns="0" rtlCol="0" anchor="ctr"/>
-          <a:lstStyle/>
-          <a:p>
-            <a:pPr marL="0" indent="0">
-              <a:buNone/>
-            </a:pPr>
-            <a:r>
-              <a:rPr lang="en-US" sz="2000" dirty="0">
-                <a:solidFill>
-                  <a:srgbClr val="4F5B6B"/>
-                </a:solidFill>
-                <a:latin typeface="BIZ UDゴシック" pitchFamily="34" charset="0"/>
-                <a:ea typeface="BIZ UDゴシック" pitchFamily="49" charset="-128"/>
-                <a:cs typeface="BIZ UDゴシック" pitchFamily="34" charset="-120"/>
-              </a:rPr>
-              <a:t>主席医務官からの手紙（要旨）</a:t>
-            </a:r>
-            <a:endParaRPr lang="en-US" sz="2000" dirty="0"/>
-          </a:p>
-        </p:txBody>
-      </p:sp>
-      <p:sp>
-        <p:nvSpPr>
-          <p:cNvPr id="11" name="Text 7"/>
-          <p:cNvSpPr txBox="1"/>
-          <p:nvPr/>
-        </p:nvSpPr>
-        <p:spPr>
-          <a:xfrm>
-            <a:off x="868680" y="3154680"/>
-            <a:ext cx="5029200" cy="1737360"/>
-          </a:xfrm>
-          <a:prstGeom prst="rect">
-            <a:avLst/>
-          </a:prstGeom>
-          <a:noFill/>
-          <a:ln/>
-        </p:spPr>
-        <p:txBody>
-          <a:bodyPr wrap="square" lIns="0" tIns="0" rIns="0" bIns="0" rtlCol="0" anchor="ctr"/>
-          <a:lstStyle/>
-          <a:p>
-            <a:pPr marL="0" indent="0">
-              <a:buNone/>
-            </a:pPr>
-            <a:r>
-              <a:rPr lang="en-US" sz="2400" b="1" dirty="0">
-                <a:solidFill>
-                  <a:srgbClr val="131B35"/>
-                </a:solidFill>
-                <a:latin typeface="BIZ UDゴシック" pitchFamily="34" charset="0"/>
-                <a:ea typeface="BIZ UDゴシック" pitchFamily="49" charset="-128"/>
-                <a:cs typeface="BIZ UDゴシック" pitchFamily="34" charset="-120"/>
-              </a:rPr>
-              <a:t>「あなたの診療所の</a:t>
-            </a:r>
-            <a:endParaRPr lang="en-US" sz="2400" dirty="0"/>
-          </a:p>
-          <a:p>
-            <a:pPr marL="0" indent="0">
-              <a:buNone/>
-            </a:pPr>
-            <a:r>
-              <a:rPr lang="en-US" sz="2400" b="1" dirty="0">
-                <a:solidFill>
-                  <a:srgbClr val="131B35"/>
-                </a:solidFill>
-                <a:latin typeface="BIZ UDゴシック" pitchFamily="34" charset="0"/>
-                <a:ea typeface="BIZ UDゴシック" pitchFamily="49" charset="-128"/>
-                <a:cs typeface="BIZ UDゴシック" pitchFamily="34" charset="-120"/>
-              </a:rPr>
-              <a:t>抗菌薬処方は、地域の80%の</a:t>
-            </a:r>
-            <a:endParaRPr lang="en-US" sz="2400" dirty="0"/>
-          </a:p>
-          <a:p>
-            <a:pPr marL="0" indent="0">
-              <a:buNone/>
-            </a:pPr>
-            <a:r>
-              <a:rPr lang="en-US" sz="2400" b="1" dirty="0">
-                <a:solidFill>
-                  <a:srgbClr val="131B35"/>
-                </a:solidFill>
-                <a:latin typeface="BIZ UDゴシック" pitchFamily="34" charset="0"/>
-                <a:ea typeface="BIZ UDゴシック" pitchFamily="49" charset="-128"/>
-                <a:cs typeface="BIZ UDゴシック" pitchFamily="34" charset="-120"/>
-              </a:rPr>
-              <a:t>診療所より多い状況です」</a:t>
-            </a:r>
-            <a:endParaRPr lang="en-US" sz="2400" dirty="0"/>
-          </a:p>
-        </p:txBody>
-      </p:sp>
-      <p:sp>
-        <p:nvSpPr>
-          <p:cNvPr id="12" name="Text 8"/>
-          <p:cNvSpPr txBox="1"/>
-          <p:nvPr/>
-        </p:nvSpPr>
-        <p:spPr>
-          <a:xfrm>
-            <a:off x="868680" y="5120640"/>
-            <a:ext cx="5029200" cy="457200"/>
-          </a:xfrm>
-          <a:prstGeom prst="rect">
-            <a:avLst/>
-          </a:prstGeom>
-          <a:noFill/>
-          <a:ln/>
-        </p:spPr>
-        <p:txBody>
-          <a:bodyPr wrap="square" lIns="0" tIns="0" rIns="0" bIns="0" rtlCol="0" anchor="t"/>
-          <a:lstStyle/>
-          <a:p>
-            <a:pPr marL="0" indent="0">
-              <a:buNone/>
-            </a:pPr>
-            <a:r>
-              <a:rPr lang="en-US" sz="2000" dirty="0">
-                <a:solidFill>
-                  <a:srgbClr val="4F5B6B"/>
-                </a:solidFill>
-                <a:latin typeface="BIZ UDゴシック" pitchFamily="34" charset="0"/>
-                <a:ea typeface="BIZ UDゴシック" pitchFamily="49" charset="-128"/>
-                <a:cs typeface="BIZ UDゴシック" pitchFamily="34" charset="-120"/>
-              </a:rPr>
-              <a:t>＋ 患者さん向けのリーフレット</a:t>
-            </a:r>
-            <a:endParaRPr lang="en-US" sz="2000" dirty="0"/>
-          </a:p>
-        </p:txBody>
-      </p:sp>
-      <p:sp>
-        <p:nvSpPr>
-          <p:cNvPr id="13" name="Text 9"/>
-          <p:cNvSpPr txBox="1"/>
-          <p:nvPr/>
-        </p:nvSpPr>
-        <p:spPr>
-          <a:xfrm>
-            <a:off x="6583680" y="1965960"/>
-            <a:ext cx="5059375" cy="960120"/>
-          </a:xfrm>
-          <a:prstGeom prst="rect">
-            <a:avLst/>
-          </a:prstGeom>
-          <a:noFill/>
-          <a:ln/>
-        </p:spPr>
-        <p:txBody>
-          <a:bodyPr wrap="square" lIns="0" tIns="0" rIns="0" bIns="0" rtlCol="0" anchor="ctr"/>
-          <a:lstStyle/>
-          <a:p>
-            <a:pPr marL="0" indent="0" algn="ctr">
-              <a:buNone/>
-            </a:pPr>
-            <a:r>
-              <a:rPr lang="en-US" sz="6000" b="1" dirty="0">
-                <a:solidFill>
-                  <a:srgbClr val="0B7A70"/>
-                </a:solidFill>
-                <a:latin typeface="BIZ UDゴシック" pitchFamily="34" charset="0"/>
-                <a:ea typeface="BIZ UDゴシック" pitchFamily="49" charset="-128"/>
-                <a:cs typeface="BIZ UDゴシック" pitchFamily="34" charset="-120"/>
-              </a:rPr>
-              <a:t>−3.3%</a:t>
-            </a:r>
-            <a:endParaRPr lang="en-US" sz="6000" dirty="0"/>
-          </a:p>
-        </p:txBody>
-      </p:sp>
-      <p:sp>
-        <p:nvSpPr>
-          <p:cNvPr id="14" name="Text 10"/>
-          <p:cNvSpPr txBox="1"/>
-          <p:nvPr/>
-        </p:nvSpPr>
-        <p:spPr>
-          <a:xfrm>
-            <a:off x="6583680" y="2926080"/>
-            <a:ext cx="5059375" cy="457200"/>
-          </a:xfrm>
-          <a:prstGeom prst="rect">
-            <a:avLst/>
-          </a:prstGeom>
-          <a:noFill/>
-          <a:ln/>
-        </p:spPr>
-        <p:txBody>
-          <a:bodyPr wrap="square" lIns="0" tIns="0" rIns="0" bIns="0" rtlCol="0" anchor="t"/>
-          <a:lstStyle/>
-          <a:p>
-            <a:pPr marL="0" indent="0" algn="ctr">
-              <a:buNone/>
-            </a:pPr>
-            <a:r>
-              <a:rPr lang="en-US" sz="2200" dirty="0">
-                <a:solidFill>
-                  <a:srgbClr val="1B2333"/>
-                </a:solidFill>
-                <a:latin typeface="BIZ UDゴシック" pitchFamily="34" charset="0"/>
-                <a:ea typeface="BIZ UDゴシック" pitchFamily="49" charset="-128"/>
-                <a:cs typeface="BIZ UDゴシック" pitchFamily="34" charset="-120"/>
-              </a:rPr>
-              <a:t>抗菌薬の処方（6か月間）</a:t>
-            </a:r>
-            <a:endParaRPr lang="en-US" sz="2200" dirty="0"/>
-          </a:p>
-        </p:txBody>
-      </p:sp>
-      <p:sp>
-        <p:nvSpPr>
-          <p:cNvPr id="15" name="Text 11"/>
-          <p:cNvSpPr txBox="1"/>
-          <p:nvPr/>
-        </p:nvSpPr>
-        <p:spPr>
-          <a:xfrm>
-            <a:off x="6583680" y="3566160"/>
-            <a:ext cx="5059375" cy="822960"/>
-          </a:xfrm>
-          <a:prstGeom prst="rect">
-            <a:avLst/>
-          </a:prstGeom>
-          <a:noFill/>
-          <a:ln/>
-        </p:spPr>
-        <p:txBody>
-          <a:bodyPr wrap="square" lIns="0" tIns="0" rIns="0" bIns="0" rtlCol="0" anchor="ctr"/>
-          <a:lstStyle/>
-          <a:p>
-            <a:pPr marL="0" indent="0" algn="ctr">
-              <a:buNone/>
-            </a:pPr>
-            <a:r>
-              <a:rPr lang="en-US" sz="4400" b="1" dirty="0">
-                <a:solidFill>
-                  <a:srgbClr val="0B7A70"/>
-                </a:solidFill>
-                <a:latin typeface="BIZ UDゴシック" pitchFamily="34" charset="0"/>
-                <a:ea typeface="BIZ UDゴシック" pitchFamily="49" charset="-128"/>
-                <a:cs typeface="BIZ UDゴシック" pitchFamily="34" charset="-120"/>
-              </a:rPr>
-              <a:t>約7.3万件</a:t>
-            </a:r>
-            <a:endParaRPr lang="en-US" sz="4400" dirty="0"/>
-          </a:p>
-        </p:txBody>
-      </p:sp>
-      <p:sp>
-        <p:nvSpPr>
-          <p:cNvPr id="16" name="Text 12"/>
-          <p:cNvSpPr txBox="1"/>
-          <p:nvPr/>
-        </p:nvSpPr>
-        <p:spPr>
-          <a:xfrm>
-            <a:off x="6583680" y="4389120"/>
-            <a:ext cx="5059375" cy="457200"/>
-          </a:xfrm>
-          <a:prstGeom prst="rect">
-            <a:avLst/>
-          </a:prstGeom>
-          <a:noFill/>
-          <a:ln/>
-        </p:spPr>
-        <p:txBody>
-          <a:bodyPr wrap="square" lIns="0" tIns="0" rIns="0" bIns="0" rtlCol="0" anchor="t"/>
-          <a:lstStyle/>
-          <a:p>
-            <a:pPr marL="0" indent="0" algn="ctr">
-              <a:buNone/>
-            </a:pPr>
-            <a:r>
-              <a:rPr lang="en-US" sz="2200" dirty="0">
-                <a:solidFill>
-                  <a:srgbClr val="1B2333"/>
-                </a:solidFill>
-                <a:latin typeface="BIZ UDゴシック" pitchFamily="34" charset="0"/>
-                <a:ea typeface="BIZ UDゴシック" pitchFamily="49" charset="-128"/>
-                <a:cs typeface="BIZ UDゴシック" pitchFamily="34" charset="-120"/>
-              </a:rPr>
-              <a:t>推計の処方減少</a:t>
-            </a:r>
-            <a:endParaRPr lang="en-US" sz="2200" dirty="0"/>
-          </a:p>
-        </p:txBody>
-      </p:sp>
-      <p:sp>
-        <p:nvSpPr>
-          <p:cNvPr id="17" name="Text 13"/>
-          <p:cNvSpPr txBox="1"/>
-          <p:nvPr/>
-        </p:nvSpPr>
-        <p:spPr>
-          <a:xfrm>
-            <a:off x="6583680" y="5166360"/>
-            <a:ext cx="5059375" cy="457200"/>
-          </a:xfrm>
-          <a:prstGeom prst="rect">
-            <a:avLst/>
-          </a:prstGeom>
-          <a:noFill/>
-          <a:ln/>
-        </p:spPr>
-        <p:txBody>
-          <a:bodyPr wrap="square" lIns="0" tIns="0" rIns="0" bIns="0" rtlCol="0" anchor="t"/>
-          <a:lstStyle/>
-          <a:p>
-            <a:pPr marL="0" indent="0" algn="ctr">
-              <a:buNone/>
-            </a:pPr>
-            <a:r>
-              <a:rPr lang="en-US" sz="2000" dirty="0">
-                <a:solidFill>
-                  <a:srgbClr val="4F5B6B"/>
-                </a:solidFill>
-                <a:latin typeface="BIZ UDゴシック" pitchFamily="34" charset="0"/>
-                <a:ea typeface="BIZ UDゴシック" pitchFamily="49" charset="-128"/>
-                <a:cs typeface="BIZ UDゴシック" pitchFamily="34" charset="-120"/>
-              </a:rPr>
-              <a:t>1,581診療所のランダム化比較試験</a:t>
-            </a:r>
-            <a:endParaRPr lang="en-US" sz="2000" dirty="0"/>
-          </a:p>
-        </p:txBody>
-      </p:sp>
-      <p:sp>
-        <p:nvSpPr>
-          <p:cNvPr id="25" name="Slide Number Placeholder 0"/>
-          <p:cNvSpPr>
-            <a:spLocks noGrp="1"/>
-          </p:cNvSpPr>
-          <p:nvPr>
-            <p:ph type="sldNum" sz="quarter" idx="4294967295"/>
-          </p:nvPr>
-        </p:nvSpPr>
-        <p:spPr>
-          <a:xfrm>
-            <a:off x="11000232" y="6217920"/>
-            <a:ext cx="640080" cy="384048"/>
-          </a:xfrm>
-          <a:prstGeom prst="rect">
-            <a:avLst/>
-          </a:prstGeom>
-          <a:extLst>
-            <a:ext uri="{C572A759-6A51-4108-AA02-DFA0A04FC94B}">
-              <ma14:wrappingTextBoxFlag xmlns="" xmlns:ma14="http://schemas.microsoft.com/office/mac/drawingml/2011/main" val="0"/>
-            </a:ext>
-          </a:extLst>
-        </p:spPr>
-        <p:txBody>
-          <a:bodyPr/>
-          <a:lstStyle>
-            <a:lvl1pPr>
-              <a:defRPr sz="2000">
-                <a:solidFill>
-                  <a:srgbClr val="8A96A8"/>
-                </a:solidFill>
-                <a:latin typeface="BIZ UDゴシック"/>
-                <a:ea typeface="BIZ UDゴシック"/>
-                <a:cs typeface="BIZ UDゴシック"/>
-              </a:defRPr>
-            </a:lvl1pPr>
-          </a:lstStyle>
-          <a:p>
-            <a:pPr algn="r"/>
-            <a:fld id="{F7021451-1387-4CA6-816F-3879F97B5CBC}" type="slidenum">
-              <a:rPr lang="en-US" b="0"/>
-              <a:t>29</a:t>
-            </a:fld>
-            <a:endParaRPr lang="en-US"/>
-          </a:p>
-        </p:txBody>
-      </p:sp>
-    </p:spTree>
-  </p:cSld>
-  <p:clrMapOvr>
-    <a:masterClrMapping/>
-  </p:clrMapOvr>
-</p:sld>
-</file>
-
 <file path=ppt/slides/slide3.xml><?xml version="1.0" encoding="utf-8"?>
 <p:sld xmlns:a="http://schemas.openxmlformats.org/drawingml/2006/main" xmlns:r="http://schemas.openxmlformats.org/officeDocument/2006/relationships" xmlns:p="http://schemas.openxmlformats.org/presentationml/2006/main">
   <p:cSld name="Slide 3">
@@ -21416,7 +20675,7 @@
                 <a:ea typeface="BIZ UDゴシック" pitchFamily="49" charset="-128"/>
                 <a:cs typeface="BIZ UDゴシック" pitchFamily="34" charset="-120"/>
               </a:rPr>
-              <a:t>見える化③ 当院の実践</a:t>
+              <a:t>見える化② 当院の実践</a:t>
             </a:r>
             <a:endParaRPr lang="en-US" sz="2000" dirty="0"/>
           </a:p>
@@ -24979,7 +24238,7 @@
                           <a:ea typeface="BIZ UDゴシック" pitchFamily="49" charset="-128"/>
                           <a:cs typeface="BIZ UDゴシック" pitchFamily="34" charset="-120"/>
                         </a:rPr>
-                        <a:t>自分の処方の多さが見えない</a:t>
+                        <a:t>回診で「触れる前」が抜ける</a:t>
                       </a:r>
                       <a:endParaRPr lang="en-US" sz="2000" dirty="0">
                         <a:latin typeface="BIZ UDゴシック" charset="0"/>
@@ -25047,7 +24306,7 @@
                           <a:ea typeface="BIZ UDゴシック" pitchFamily="49" charset="-128"/>
                           <a:cs typeface="BIZ UDゴシック" pitchFamily="34" charset="-120"/>
                         </a:rPr>
-                        <a:t>処方データの同僚比較</a:t>
+                        <a:t>先頭の人が最初に手指衛生</a:t>
                       </a:r>
                       <a:endParaRPr lang="en-US" sz="2000" dirty="0">
                         <a:latin typeface="BIZ UDゴシック" charset="0"/>
@@ -35549,7 +34808,7 @@
                 <a:ea typeface="BIZ UDゴシック" pitchFamily="49" charset="-128"/>
                 <a:cs typeface="BIZ UDゴシック" pitchFamily="34" charset="-120"/>
               </a:rPr>
-              <a:t>見える化③ 当院の実践</a:t>
+              <a:t>見える化② 当院の実践</a:t>
             </a:r>
             <a:endParaRPr lang="en-US" sz="2000" dirty="0"/>
           </a:p>

</xml_diff>